<commit_message>
Update H4 Application Programming Interfaces - Dynamische Websites.pptx
</commit_message>
<xml_diff>
--- a/H4 - Application Programming Interfaces/Presentatie/H4 Application Programming Interfaces - Dynamische Websites.pptx
+++ b/H4 - Application Programming Interfaces/Presentatie/H4 Application Programming Interfaces - Dynamische Websites.pptx
@@ -5,14 +5,15 @@
     <p:sldMasterId id="2147483696" r:id="rId1"/>
   </p:sldMasterIdLst>
   <p:notesMasterIdLst>
-    <p:notesMasterId r:id="rId7"/>
+    <p:notesMasterId r:id="rId8"/>
   </p:notesMasterIdLst>
   <p:sldIdLst>
     <p:sldId id="256" r:id="rId2"/>
     <p:sldId id="273" r:id="rId3"/>
     <p:sldId id="275" r:id="rId4"/>
     <p:sldId id="274" r:id="rId5"/>
-    <p:sldId id="272" r:id="rId6"/>
+    <p:sldId id="276" r:id="rId6"/>
+    <p:sldId id="272" r:id="rId7"/>
   </p:sldIdLst>
   <p:sldSz cx="12192000" cy="6858000"/>
   <p:notesSz cx="6858000" cy="9144000"/>
@@ -118,6 +119,7 @@
 <p1510:revInfo xmlns:a="http://schemas.openxmlformats.org/drawingml/2006/main" xmlns:r="http://schemas.openxmlformats.org/officeDocument/2006/relationships" xmlns:p1510="http://schemas.microsoft.com/office/powerpoint/2015/10/main">
   <p1510:revLst>
     <p1510:client id="{6BFF463E-B11A-78E2-C9E0-45860F4C75E4}" v="296" dt="2026-03-02T17:50:28.862"/>
+    <p1510:client id="{B62DBB2E-7CB5-5C85-4417-1BE7428C5980}" v="284" dt="2026-03-03T07:33:59.320"/>
   </p1510:revLst>
 </p1510:revInfo>
 </file>
@@ -4051,7 +4053,7 @@
           <a:p>
             <a:fld id="{39DBD449-D42A-4711-8837-53EC15580D9C}" type="slidenum">
               <a:rPr lang="nl-BE" smtClean="0"/>
-              <a:t>3</a:t>
+              <a:t>4</a:t>
             </a:fld>
             <a:endParaRPr lang="nl-BE"/>
           </a:p>
@@ -4071,6 +4073,1179 @@
 </file>
 
 <file path=ppt/notesSlides/notesSlide5.xml><?xml version="1.0" encoding="utf-8"?>
+<p:notes xmlns:a="http://schemas.openxmlformats.org/drawingml/2006/main" xmlns:r="http://schemas.openxmlformats.org/officeDocument/2006/relationships" xmlns:p="http://schemas.openxmlformats.org/presentationml/2006/main">
+  <p:cSld>
+    <p:spTree>
+      <p:nvGrpSpPr>
+        <p:cNvPr id="1" name="">
+          <a:extLst>
+            <a:ext uri="{FF2B5EF4-FFF2-40B4-BE49-F238E27FC236}">
+              <a16:creationId xmlns:a16="http://schemas.microsoft.com/office/drawing/2014/main" id="{B1607289-4631-6BC9-7884-84D774A110D8}"/>
+            </a:ext>
+          </a:extLst>
+        </p:cNvPr>
+        <p:cNvGrpSpPr/>
+        <p:nvPr/>
+      </p:nvGrpSpPr>
+      <p:grpSpPr>
+        <a:xfrm>
+          <a:off x="0" y="0"/>
+          <a:ext cx="0" cy="0"/>
+          <a:chOff x="0" y="0"/>
+          <a:chExt cx="0" cy="0"/>
+        </a:xfrm>
+      </p:grpSpPr>
+      <p:sp>
+        <p:nvSpPr>
+          <p:cNvPr id="2" name="Tijdelijke aanduiding voor dia-afbeelding 1">
+            <a:extLst>
+              <a:ext uri="{FF2B5EF4-FFF2-40B4-BE49-F238E27FC236}">
+                <a16:creationId xmlns:a16="http://schemas.microsoft.com/office/drawing/2014/main" id="{DEC33C88-A0ED-91FD-A375-1ED2EACA8775}"/>
+              </a:ext>
+            </a:extLst>
+          </p:cNvPr>
+          <p:cNvSpPr>
+            <a:spLocks noGrp="1" noRot="1" noChangeAspect="1"/>
+          </p:cNvSpPr>
+          <p:nvPr>
+            <p:ph type="sldImg"/>
+          </p:nvPr>
+        </p:nvSpPr>
+        <p:spPr/>
+      </p:sp>
+      <p:sp>
+        <p:nvSpPr>
+          <p:cNvPr id="3" name="Tijdelijke aanduiding voor notities 2">
+            <a:extLst>
+              <a:ext uri="{FF2B5EF4-FFF2-40B4-BE49-F238E27FC236}">
+                <a16:creationId xmlns:a16="http://schemas.microsoft.com/office/drawing/2014/main" id="{56DD2799-19BA-9345-3D1B-A870ECBF067A}"/>
+              </a:ext>
+            </a:extLst>
+          </p:cNvPr>
+          <p:cNvSpPr>
+            <a:spLocks noGrp="1"/>
+          </p:cNvSpPr>
+          <p:nvPr>
+            <p:ph type="body" idx="1"/>
+          </p:nvPr>
+        </p:nvSpPr>
+        <p:spPr/>
+        <p:txBody>
+          <a:bodyPr/>
+          <a:lstStyle/>
+          <a:p>
+            <a:r>
+              <a:rPr lang="en-US" dirty="0">
+                <a:latin typeface="Calibri"/>
+                <a:ea typeface="Calibri"/>
+                <a:cs typeface="Calibri"/>
+              </a:rPr>
+              <a:t>Een Application Programming Interface of API </a:t>
+            </a:r>
+            <a:r>
+              <a:rPr lang="en-US" dirty="0" err="1">
+                <a:latin typeface="Calibri"/>
+                <a:ea typeface="Calibri"/>
+                <a:cs typeface="Calibri"/>
+              </a:rPr>
+              <a:t>fungeert</a:t>
+            </a:r>
+            <a:r>
+              <a:rPr lang="en-US" dirty="0">
+                <a:latin typeface="Calibri"/>
+                <a:ea typeface="Calibri"/>
+                <a:cs typeface="Calibri"/>
+              </a:rPr>
+              <a:t> </a:t>
+            </a:r>
+            <a:r>
+              <a:rPr lang="en-US" dirty="0" err="1">
+                <a:latin typeface="Calibri"/>
+                <a:ea typeface="Calibri"/>
+                <a:cs typeface="Calibri"/>
+              </a:rPr>
+              <a:t>vaak</a:t>
+            </a:r>
+            <a:r>
+              <a:rPr lang="en-US" dirty="0">
+                <a:latin typeface="Calibri"/>
+                <a:ea typeface="Calibri"/>
+                <a:cs typeface="Calibri"/>
+              </a:rPr>
+              <a:t> </a:t>
+            </a:r>
+            <a:r>
+              <a:rPr lang="en-US" dirty="0" err="1">
+                <a:latin typeface="Calibri"/>
+                <a:ea typeface="Calibri"/>
+                <a:cs typeface="Calibri"/>
+              </a:rPr>
+              <a:t>als</a:t>
+            </a:r>
+            <a:r>
+              <a:rPr lang="en-US" dirty="0">
+                <a:latin typeface="Calibri"/>
+                <a:ea typeface="Calibri"/>
+                <a:cs typeface="Calibri"/>
+              </a:rPr>
+              <a:t> </a:t>
+            </a:r>
+            <a:r>
+              <a:rPr lang="en-US" dirty="0" err="1">
+                <a:latin typeface="Calibri"/>
+                <a:ea typeface="Calibri"/>
+                <a:cs typeface="Calibri"/>
+              </a:rPr>
+              <a:t>tussenlaag</a:t>
+            </a:r>
+            <a:r>
+              <a:rPr lang="en-US" dirty="0">
+                <a:latin typeface="Calibri"/>
+                <a:ea typeface="Calibri"/>
+                <a:cs typeface="Calibri"/>
+              </a:rPr>
+              <a:t> die </a:t>
+            </a:r>
+            <a:r>
+              <a:rPr lang="en-US" dirty="0" err="1">
+                <a:latin typeface="Calibri"/>
+                <a:ea typeface="Calibri"/>
+                <a:cs typeface="Calibri"/>
+              </a:rPr>
+              <a:t>een</a:t>
+            </a:r>
+            <a:r>
+              <a:rPr lang="en-US" dirty="0">
+                <a:latin typeface="Calibri"/>
+                <a:ea typeface="Calibri"/>
+                <a:cs typeface="Calibri"/>
+              </a:rPr>
+              <a:t> developer </a:t>
+            </a:r>
+            <a:r>
+              <a:rPr lang="en-US" dirty="0" err="1">
+                <a:latin typeface="Calibri"/>
+                <a:ea typeface="Calibri"/>
+                <a:cs typeface="Calibri"/>
+              </a:rPr>
+              <a:t>heeft</a:t>
+            </a:r>
+            <a:r>
+              <a:rPr lang="en-US" dirty="0">
+                <a:latin typeface="Calibri"/>
+                <a:ea typeface="Calibri"/>
+                <a:cs typeface="Calibri"/>
+              </a:rPr>
+              <a:t> </a:t>
+            </a:r>
+            <a:r>
+              <a:rPr lang="en-US" dirty="0" err="1">
+                <a:latin typeface="Calibri"/>
+                <a:ea typeface="Calibri"/>
+                <a:cs typeface="Calibri"/>
+              </a:rPr>
+              <a:t>gemaakt</a:t>
+            </a:r>
+            <a:r>
+              <a:rPr lang="en-US" dirty="0">
+                <a:latin typeface="Calibri"/>
+                <a:ea typeface="Calibri"/>
+                <a:cs typeface="Calibri"/>
+              </a:rPr>
+              <a:t> om </a:t>
+            </a:r>
+            <a:r>
+              <a:rPr lang="en-US" dirty="0" err="1">
+                <a:latin typeface="Calibri"/>
+                <a:ea typeface="Calibri"/>
+                <a:cs typeface="Calibri"/>
+              </a:rPr>
+              <a:t>gegevens</a:t>
+            </a:r>
+            <a:r>
+              <a:rPr lang="en-US" dirty="0">
+                <a:latin typeface="Calibri"/>
+                <a:ea typeface="Calibri"/>
+                <a:cs typeface="Calibri"/>
+              </a:rPr>
+              <a:t> </a:t>
+            </a:r>
+            <a:r>
+              <a:rPr lang="en-US" dirty="0" err="1">
+                <a:latin typeface="Calibri"/>
+                <a:ea typeface="Calibri"/>
+                <a:cs typeface="Calibri"/>
+              </a:rPr>
+              <a:t>uit</a:t>
+            </a:r>
+            <a:r>
+              <a:rPr lang="en-US" dirty="0">
+                <a:latin typeface="Calibri"/>
+                <a:ea typeface="Calibri"/>
+                <a:cs typeface="Calibri"/>
+              </a:rPr>
+              <a:t> </a:t>
+            </a:r>
+            <a:r>
+              <a:rPr lang="en-US" dirty="0" err="1">
+                <a:latin typeface="Calibri"/>
+                <a:ea typeface="Calibri"/>
+                <a:cs typeface="Calibri"/>
+              </a:rPr>
+              <a:t>te</a:t>
+            </a:r>
+            <a:r>
+              <a:rPr lang="en-US" dirty="0">
+                <a:latin typeface="Calibri"/>
+                <a:ea typeface="Calibri"/>
+                <a:cs typeface="Calibri"/>
+              </a:rPr>
+              <a:t> </a:t>
+            </a:r>
+            <a:r>
+              <a:rPr lang="en-US" dirty="0" err="1">
+                <a:latin typeface="Calibri"/>
+                <a:ea typeface="Calibri"/>
+                <a:cs typeface="Calibri"/>
+              </a:rPr>
+              <a:t>wisselen</a:t>
+            </a:r>
+            <a:r>
+              <a:rPr lang="en-US" dirty="0">
+                <a:latin typeface="Calibri"/>
+                <a:ea typeface="Calibri"/>
+                <a:cs typeface="Calibri"/>
+              </a:rPr>
+              <a:t> met </a:t>
+            </a:r>
+            <a:r>
+              <a:rPr lang="en-US" dirty="0" err="1">
+                <a:latin typeface="Calibri"/>
+                <a:ea typeface="Calibri"/>
+                <a:cs typeface="Calibri"/>
+              </a:rPr>
+              <a:t>andere</a:t>
+            </a:r>
+            <a:r>
+              <a:rPr lang="en-US" dirty="0">
+                <a:latin typeface="Calibri"/>
+                <a:ea typeface="Calibri"/>
+                <a:cs typeface="Calibri"/>
+              </a:rPr>
+              <a:t> </a:t>
+            </a:r>
+            <a:r>
+              <a:rPr lang="en-US" dirty="0" err="1">
+                <a:latin typeface="Calibri"/>
+                <a:ea typeface="Calibri"/>
+                <a:cs typeface="Calibri"/>
+              </a:rPr>
+              <a:t>applicaties</a:t>
+            </a:r>
+            <a:r>
+              <a:rPr lang="en-US" dirty="0">
+                <a:latin typeface="Calibri"/>
+                <a:ea typeface="Calibri"/>
+                <a:cs typeface="Calibri"/>
+              </a:rPr>
+              <a:t>.</a:t>
+            </a:r>
+          </a:p>
+          <a:p>
+            <a:endParaRPr lang="en-US" dirty="0">
+              <a:latin typeface="Calibri"/>
+              <a:ea typeface="Calibri"/>
+              <a:cs typeface="Calibri"/>
+            </a:endParaRPr>
+          </a:p>
+          <a:p>
+            <a:r>
+              <a:rPr lang="en-US" dirty="0">
+                <a:latin typeface="Calibri"/>
+                <a:ea typeface="Calibri"/>
+                <a:cs typeface="Calibri"/>
+              </a:rPr>
+              <a:t>Als </a:t>
+            </a:r>
+            <a:r>
+              <a:rPr lang="en-US" dirty="0" err="1">
+                <a:latin typeface="Calibri"/>
+                <a:ea typeface="Calibri"/>
+                <a:cs typeface="Calibri"/>
+              </a:rPr>
+              <a:t>jij</a:t>
+            </a:r>
+            <a:r>
+              <a:rPr lang="en-US" dirty="0">
+                <a:latin typeface="Calibri"/>
+                <a:ea typeface="Calibri"/>
+                <a:cs typeface="Calibri"/>
+              </a:rPr>
+              <a:t> </a:t>
+            </a:r>
+            <a:r>
+              <a:rPr lang="en-US" dirty="0" err="1">
+                <a:latin typeface="Calibri"/>
+                <a:ea typeface="Calibri"/>
+                <a:cs typeface="Calibri"/>
+              </a:rPr>
+              <a:t>dus</a:t>
+            </a:r>
+            <a:r>
+              <a:rPr lang="en-US" dirty="0">
+                <a:latin typeface="Calibri"/>
+                <a:ea typeface="Calibri"/>
+                <a:cs typeface="Calibri"/>
+              </a:rPr>
+              <a:t> </a:t>
+            </a:r>
+            <a:r>
+              <a:rPr lang="en-US" dirty="0" err="1">
+                <a:latin typeface="Calibri"/>
+                <a:ea typeface="Calibri"/>
+                <a:cs typeface="Calibri"/>
+              </a:rPr>
+              <a:t>een</a:t>
+            </a:r>
+            <a:r>
+              <a:rPr lang="en-US" dirty="0">
+                <a:latin typeface="Calibri"/>
+                <a:ea typeface="Calibri"/>
+                <a:cs typeface="Calibri"/>
+              </a:rPr>
+              <a:t> </a:t>
+            </a:r>
+            <a:r>
+              <a:rPr lang="en-US" dirty="0" err="1">
+                <a:latin typeface="Calibri"/>
+                <a:ea typeface="Calibri"/>
+                <a:cs typeface="Calibri"/>
+              </a:rPr>
+              <a:t>applicatie</a:t>
+            </a:r>
+            <a:r>
+              <a:rPr lang="en-US" dirty="0">
+                <a:latin typeface="Calibri"/>
+                <a:ea typeface="Calibri"/>
+                <a:cs typeface="Calibri"/>
+              </a:rPr>
+              <a:t> </a:t>
+            </a:r>
+            <a:r>
+              <a:rPr lang="en-US" dirty="0" err="1">
+                <a:latin typeface="Calibri"/>
+                <a:ea typeface="Calibri"/>
+                <a:cs typeface="Calibri"/>
+              </a:rPr>
+              <a:t>maakt</a:t>
+            </a:r>
+            <a:r>
+              <a:rPr lang="en-US" dirty="0">
+                <a:latin typeface="Calibri"/>
+                <a:ea typeface="Calibri"/>
+                <a:cs typeface="Calibri"/>
+              </a:rPr>
+              <a:t> om je </a:t>
+            </a:r>
+            <a:r>
+              <a:rPr lang="en-US" dirty="0" err="1">
+                <a:latin typeface="Calibri"/>
+                <a:ea typeface="Calibri"/>
+                <a:cs typeface="Calibri"/>
+              </a:rPr>
+              <a:t>vrienden</a:t>
+            </a:r>
+            <a:r>
+              <a:rPr lang="en-US" dirty="0">
+                <a:latin typeface="Calibri"/>
+                <a:ea typeface="Calibri"/>
+                <a:cs typeface="Calibri"/>
+              </a:rPr>
+              <a:t> </a:t>
+            </a:r>
+            <a:r>
+              <a:rPr lang="en-US" dirty="0" err="1">
+                <a:latin typeface="Calibri"/>
+                <a:ea typeface="Calibri"/>
+                <a:cs typeface="Calibri"/>
+              </a:rPr>
+              <a:t>te</a:t>
+            </a:r>
+            <a:r>
+              <a:rPr lang="en-US" dirty="0">
+                <a:latin typeface="Calibri"/>
+                <a:ea typeface="Calibri"/>
+                <a:cs typeface="Calibri"/>
+              </a:rPr>
+              <a:t> </a:t>
+            </a:r>
+            <a:r>
+              <a:rPr lang="en-US" dirty="0" err="1">
+                <a:latin typeface="Calibri"/>
+                <a:ea typeface="Calibri"/>
+                <a:cs typeface="Calibri"/>
+              </a:rPr>
+              <a:t>zoeken</a:t>
+            </a:r>
+            <a:r>
+              <a:rPr lang="en-US" dirty="0">
+                <a:latin typeface="Calibri"/>
+                <a:ea typeface="Calibri"/>
+                <a:cs typeface="Calibri"/>
+              </a:rPr>
+              <a:t>: dan is het </a:t>
+            </a:r>
+            <a:r>
+              <a:rPr lang="en-US" dirty="0" err="1">
+                <a:latin typeface="Calibri"/>
+                <a:ea typeface="Calibri"/>
+                <a:cs typeface="Calibri"/>
+              </a:rPr>
+              <a:t>handig</a:t>
+            </a:r>
+            <a:r>
+              <a:rPr lang="en-US" dirty="0">
+                <a:latin typeface="Calibri"/>
+                <a:ea typeface="Calibri"/>
+                <a:cs typeface="Calibri"/>
+              </a:rPr>
+              <a:t> om Facebook </a:t>
+            </a:r>
+            <a:r>
+              <a:rPr lang="en-US" dirty="0" err="1">
+                <a:latin typeface="Calibri"/>
+                <a:ea typeface="Calibri"/>
+                <a:cs typeface="Calibri"/>
+              </a:rPr>
+              <a:t>te</a:t>
+            </a:r>
+            <a:r>
+              <a:rPr lang="en-US" dirty="0">
+                <a:latin typeface="Calibri"/>
+                <a:ea typeface="Calibri"/>
+                <a:cs typeface="Calibri"/>
+              </a:rPr>
+              <a:t> </a:t>
+            </a:r>
+            <a:r>
+              <a:rPr lang="en-US" dirty="0" err="1">
+                <a:latin typeface="Calibri"/>
+                <a:ea typeface="Calibri"/>
+                <a:cs typeface="Calibri"/>
+              </a:rPr>
+              <a:t>gebruiken</a:t>
+            </a:r>
+            <a:r>
+              <a:rPr lang="en-US" dirty="0">
+                <a:latin typeface="Calibri"/>
+                <a:ea typeface="Calibri"/>
+                <a:cs typeface="Calibri"/>
+              </a:rPr>
+              <a:t> </a:t>
+            </a:r>
+            <a:r>
+              <a:rPr lang="en-US" dirty="0" err="1">
+                <a:latin typeface="Calibri"/>
+                <a:ea typeface="Calibri"/>
+                <a:cs typeface="Calibri"/>
+              </a:rPr>
+              <a:t>als</a:t>
+            </a:r>
+            <a:r>
+              <a:rPr lang="en-US" dirty="0">
+                <a:latin typeface="Calibri"/>
+                <a:ea typeface="Calibri"/>
+                <a:cs typeface="Calibri"/>
+              </a:rPr>
+              <a:t> </a:t>
+            </a:r>
+            <a:r>
+              <a:rPr lang="en-US" dirty="0" err="1">
+                <a:latin typeface="Calibri"/>
+                <a:ea typeface="Calibri"/>
+                <a:cs typeface="Calibri"/>
+              </a:rPr>
+              <a:t>contactenboek</a:t>
+            </a:r>
+            <a:r>
+              <a:rPr lang="en-US" dirty="0">
+                <a:latin typeface="Calibri"/>
+                <a:ea typeface="Calibri"/>
+                <a:cs typeface="Calibri"/>
+              </a:rPr>
+              <a:t>. Je </a:t>
+            </a:r>
+            <a:r>
+              <a:rPr lang="en-US" dirty="0" err="1">
+                <a:latin typeface="Calibri"/>
+                <a:ea typeface="Calibri"/>
+                <a:cs typeface="Calibri"/>
+              </a:rPr>
+              <a:t>kan</a:t>
+            </a:r>
+            <a:r>
+              <a:rPr lang="en-US" dirty="0">
+                <a:latin typeface="Calibri"/>
+                <a:ea typeface="Calibri"/>
+                <a:cs typeface="Calibri"/>
+              </a:rPr>
+              <a:t> </a:t>
+            </a:r>
+            <a:r>
+              <a:rPr lang="en-US" dirty="0" err="1">
+                <a:latin typeface="Calibri"/>
+                <a:ea typeface="Calibri"/>
+                <a:cs typeface="Calibri"/>
+              </a:rPr>
+              <a:t>dit</a:t>
+            </a:r>
+            <a:r>
+              <a:rPr lang="en-US" dirty="0">
+                <a:latin typeface="Calibri"/>
+                <a:ea typeface="Calibri"/>
+                <a:cs typeface="Calibri"/>
+              </a:rPr>
+              <a:t> </a:t>
+            </a:r>
+            <a:r>
+              <a:rPr lang="en-US" dirty="0" err="1">
+                <a:latin typeface="Calibri"/>
+                <a:ea typeface="Calibri"/>
+                <a:cs typeface="Calibri"/>
+              </a:rPr>
+              <a:t>ook</a:t>
+            </a:r>
+            <a:r>
+              <a:rPr lang="en-US" dirty="0">
+                <a:latin typeface="Calibri"/>
+                <a:ea typeface="Calibri"/>
+                <a:cs typeface="Calibri"/>
+              </a:rPr>
+              <a:t> </a:t>
+            </a:r>
+            <a:r>
+              <a:rPr lang="en-US" dirty="0" err="1">
+                <a:latin typeface="Calibri"/>
+                <a:ea typeface="Calibri"/>
+                <a:cs typeface="Calibri"/>
+              </a:rPr>
+              <a:t>combineren</a:t>
+            </a:r>
+            <a:r>
+              <a:rPr lang="en-US" dirty="0">
+                <a:latin typeface="Calibri"/>
+                <a:ea typeface="Calibri"/>
+                <a:cs typeface="Calibri"/>
+              </a:rPr>
+              <a:t>: </a:t>
+            </a:r>
+            <a:r>
+              <a:rPr lang="en-US" dirty="0" err="1">
+                <a:latin typeface="Calibri"/>
+                <a:ea typeface="Calibri"/>
+                <a:cs typeface="Calibri"/>
+              </a:rPr>
+              <a:t>bijvoorbeeld</a:t>
+            </a:r>
+            <a:r>
+              <a:rPr lang="en-US" dirty="0">
+                <a:latin typeface="Calibri"/>
+                <a:ea typeface="Calibri"/>
+                <a:cs typeface="Calibri"/>
+              </a:rPr>
+              <a:t> de Facebook API </a:t>
+            </a:r>
+            <a:r>
+              <a:rPr lang="en-US" dirty="0" err="1">
+                <a:latin typeface="Calibri"/>
+                <a:ea typeface="Calibri"/>
+                <a:cs typeface="Calibri"/>
+              </a:rPr>
+              <a:t>én</a:t>
+            </a:r>
+            <a:r>
+              <a:rPr lang="en-US" dirty="0">
+                <a:latin typeface="Calibri"/>
+                <a:ea typeface="Calibri"/>
+                <a:cs typeface="Calibri"/>
+              </a:rPr>
+              <a:t> de Snapchat API: je </a:t>
+            </a:r>
+            <a:r>
+              <a:rPr lang="en-US" dirty="0" err="1">
+                <a:latin typeface="Calibri"/>
+                <a:ea typeface="Calibri"/>
+                <a:cs typeface="Calibri"/>
+              </a:rPr>
+              <a:t>maakt</a:t>
+            </a:r>
+            <a:r>
+              <a:rPr lang="en-US" dirty="0">
+                <a:latin typeface="Calibri"/>
+                <a:ea typeface="Calibri"/>
+                <a:cs typeface="Calibri"/>
+              </a:rPr>
+              <a:t> </a:t>
+            </a:r>
+            <a:r>
+              <a:rPr lang="en-US" dirty="0" err="1">
+                <a:latin typeface="Calibri"/>
+                <a:ea typeface="Calibri"/>
+                <a:cs typeface="Calibri"/>
+              </a:rPr>
+              <a:t>meer</a:t>
+            </a:r>
+            <a:r>
+              <a:rPr lang="en-US" dirty="0">
+                <a:latin typeface="Calibri"/>
+                <a:ea typeface="Calibri"/>
+                <a:cs typeface="Calibri"/>
+              </a:rPr>
+              <a:t> </a:t>
+            </a:r>
+            <a:r>
+              <a:rPr lang="en-US" dirty="0" err="1">
+                <a:latin typeface="Calibri"/>
+                <a:ea typeface="Calibri"/>
+                <a:cs typeface="Calibri"/>
+              </a:rPr>
+              <a:t>kans</a:t>
+            </a:r>
+            <a:r>
+              <a:rPr lang="en-US" dirty="0">
+                <a:latin typeface="Calibri"/>
+                <a:ea typeface="Calibri"/>
+                <a:cs typeface="Calibri"/>
+              </a:rPr>
+              <a:t> om </a:t>
+            </a:r>
+            <a:r>
+              <a:rPr lang="en-US" dirty="0" err="1">
+                <a:latin typeface="Calibri"/>
+                <a:ea typeface="Calibri"/>
+                <a:cs typeface="Calibri"/>
+              </a:rPr>
+              <a:t>mensen</a:t>
+            </a:r>
+            <a:r>
+              <a:rPr lang="en-US" dirty="0">
+                <a:latin typeface="Calibri"/>
+                <a:ea typeface="Calibri"/>
+                <a:cs typeface="Calibri"/>
+              </a:rPr>
+              <a:t> </a:t>
+            </a:r>
+            <a:r>
+              <a:rPr lang="en-US" dirty="0" err="1">
+                <a:latin typeface="Calibri"/>
+                <a:ea typeface="Calibri"/>
+                <a:cs typeface="Calibri"/>
+              </a:rPr>
+              <a:t>te</a:t>
+            </a:r>
+            <a:r>
+              <a:rPr lang="en-US" dirty="0">
+                <a:latin typeface="Calibri"/>
+                <a:ea typeface="Calibri"/>
+                <a:cs typeface="Calibri"/>
+              </a:rPr>
+              <a:t> </a:t>
+            </a:r>
+            <a:r>
+              <a:rPr lang="en-US" dirty="0" err="1">
+                <a:latin typeface="Calibri"/>
+                <a:ea typeface="Calibri"/>
+                <a:cs typeface="Calibri"/>
+              </a:rPr>
+              <a:t>vinden</a:t>
+            </a:r>
+            <a:r>
+              <a:rPr lang="en-US" dirty="0">
+                <a:latin typeface="Calibri"/>
+                <a:ea typeface="Calibri"/>
+                <a:cs typeface="Calibri"/>
+              </a:rPr>
+              <a:t> die je </a:t>
+            </a:r>
+            <a:r>
+              <a:rPr lang="en-US" dirty="0" err="1">
+                <a:latin typeface="Calibri"/>
+                <a:ea typeface="Calibri"/>
+                <a:cs typeface="Calibri"/>
+              </a:rPr>
+              <a:t>zoekt</a:t>
+            </a:r>
+            <a:r>
+              <a:rPr lang="en-US" dirty="0">
+                <a:latin typeface="Calibri"/>
+                <a:ea typeface="Calibri"/>
+                <a:cs typeface="Calibri"/>
+              </a:rPr>
+              <a:t> (</a:t>
+            </a:r>
+            <a:r>
+              <a:rPr lang="en-US" dirty="0" err="1">
+                <a:latin typeface="Calibri"/>
+                <a:ea typeface="Calibri"/>
+                <a:cs typeface="Calibri"/>
+              </a:rPr>
+              <a:t>voor</a:t>
+            </a:r>
+            <a:r>
+              <a:rPr lang="en-US" dirty="0">
+                <a:latin typeface="Calibri"/>
+                <a:ea typeface="Calibri"/>
+                <a:cs typeface="Calibri"/>
+              </a:rPr>
+              <a:t> het </a:t>
+            </a:r>
+            <a:r>
+              <a:rPr lang="en-US" dirty="0" err="1">
+                <a:latin typeface="Calibri"/>
+                <a:ea typeface="Calibri"/>
+                <a:cs typeface="Calibri"/>
+              </a:rPr>
+              <a:t>geval</a:t>
+            </a:r>
+            <a:r>
+              <a:rPr lang="en-US" dirty="0">
+                <a:latin typeface="Calibri"/>
+                <a:ea typeface="Calibri"/>
+                <a:cs typeface="Calibri"/>
+              </a:rPr>
+              <a:t> </a:t>
+            </a:r>
+            <a:r>
+              <a:rPr lang="en-US" dirty="0" err="1">
+                <a:latin typeface="Calibri"/>
+                <a:ea typeface="Calibri"/>
+                <a:cs typeface="Calibri"/>
+              </a:rPr>
+              <a:t>dat</a:t>
+            </a:r>
+            <a:r>
+              <a:rPr lang="en-US" dirty="0">
+                <a:latin typeface="Calibri"/>
+                <a:ea typeface="Calibri"/>
+                <a:cs typeface="Calibri"/>
+              </a:rPr>
+              <a:t> ze </a:t>
+            </a:r>
+            <a:r>
+              <a:rPr lang="en-US" dirty="0" err="1">
+                <a:latin typeface="Calibri"/>
+                <a:ea typeface="Calibri"/>
+                <a:cs typeface="Calibri"/>
+              </a:rPr>
+              <a:t>geen</a:t>
+            </a:r>
+            <a:r>
+              <a:rPr lang="en-US" dirty="0">
+                <a:latin typeface="Calibri"/>
+                <a:ea typeface="Calibri"/>
+                <a:cs typeface="Calibri"/>
+              </a:rPr>
+              <a:t> account </a:t>
+            </a:r>
+            <a:r>
+              <a:rPr lang="en-US" dirty="0" err="1">
+                <a:latin typeface="Calibri"/>
+                <a:ea typeface="Calibri"/>
+                <a:cs typeface="Calibri"/>
+              </a:rPr>
+              <a:t>hebben</a:t>
+            </a:r>
+            <a:r>
+              <a:rPr lang="en-US" dirty="0">
+                <a:latin typeface="Calibri"/>
+                <a:ea typeface="Calibri"/>
+                <a:cs typeface="Calibri"/>
+              </a:rPr>
+              <a:t> op het platform).</a:t>
+            </a:r>
+          </a:p>
+          <a:p>
+            <a:endParaRPr lang="en-US" dirty="0">
+              <a:latin typeface="Calibri"/>
+              <a:ea typeface="Calibri"/>
+              <a:cs typeface="Calibri"/>
+            </a:endParaRPr>
+          </a:p>
+          <a:p>
+            <a:r>
+              <a:rPr lang="en-US" dirty="0">
+                <a:latin typeface="Calibri"/>
+                <a:ea typeface="Calibri"/>
+                <a:cs typeface="Calibri"/>
+              </a:rPr>
+              <a:t>Een API </a:t>
+            </a:r>
+            <a:r>
+              <a:rPr lang="en-US" dirty="0" err="1">
+                <a:latin typeface="Calibri"/>
+                <a:ea typeface="Calibri"/>
+                <a:cs typeface="Calibri"/>
+              </a:rPr>
+              <a:t>binnen</a:t>
+            </a:r>
+            <a:r>
+              <a:rPr lang="en-US" dirty="0">
+                <a:latin typeface="Calibri"/>
+                <a:ea typeface="Calibri"/>
+                <a:cs typeface="Calibri"/>
+              </a:rPr>
+              <a:t> de </a:t>
+            </a:r>
+            <a:r>
+              <a:rPr lang="en-US" dirty="0" err="1">
+                <a:latin typeface="Calibri"/>
+                <a:ea typeface="Calibri"/>
+                <a:cs typeface="Calibri"/>
+              </a:rPr>
+              <a:t>webtoepassingen</a:t>
+            </a:r>
+            <a:r>
+              <a:rPr lang="en-US" dirty="0">
+                <a:latin typeface="Calibri"/>
+                <a:ea typeface="Calibri"/>
+                <a:cs typeface="Calibri"/>
+              </a:rPr>
+              <a:t> is </a:t>
+            </a:r>
+            <a:r>
+              <a:rPr lang="en-US" dirty="0" err="1">
+                <a:latin typeface="Calibri"/>
+                <a:ea typeface="Calibri"/>
+                <a:cs typeface="Calibri"/>
+              </a:rPr>
+              <a:t>aanroepbaar</a:t>
+            </a:r>
+            <a:r>
+              <a:rPr lang="en-US" dirty="0">
+                <a:latin typeface="Calibri"/>
+                <a:ea typeface="Calibri"/>
+                <a:cs typeface="Calibri"/>
+              </a:rPr>
+              <a:t> </a:t>
+            </a:r>
+            <a:r>
+              <a:rPr lang="en-US" dirty="0" err="1">
+                <a:latin typeface="Calibri"/>
+                <a:ea typeface="Calibri"/>
+                <a:cs typeface="Calibri"/>
+              </a:rPr>
+              <a:t>binnen</a:t>
+            </a:r>
+            <a:r>
+              <a:rPr lang="en-US" dirty="0">
+                <a:latin typeface="Calibri"/>
+                <a:ea typeface="Calibri"/>
+                <a:cs typeface="Calibri"/>
+              </a:rPr>
+              <a:t> </a:t>
+            </a:r>
+            <a:r>
+              <a:rPr lang="en-US" dirty="0" err="1">
+                <a:latin typeface="Calibri"/>
+                <a:ea typeface="Calibri"/>
+                <a:cs typeface="Calibri"/>
+              </a:rPr>
+              <a:t>alles</a:t>
+            </a:r>
+            <a:r>
+              <a:rPr lang="en-US" dirty="0">
+                <a:latin typeface="Calibri"/>
+                <a:ea typeface="Calibri"/>
+                <a:cs typeface="Calibri"/>
+              </a:rPr>
+              <a:t> wat </a:t>
+            </a:r>
+            <a:r>
+              <a:rPr lang="en-US" dirty="0" err="1">
+                <a:latin typeface="Calibri"/>
+                <a:ea typeface="Calibri"/>
+                <a:cs typeface="Calibri"/>
+              </a:rPr>
+              <a:t>bereikbaar</a:t>
+            </a:r>
+            <a:r>
+              <a:rPr lang="en-US" dirty="0">
+                <a:latin typeface="Calibri"/>
+                <a:ea typeface="Calibri"/>
+                <a:cs typeface="Calibri"/>
+              </a:rPr>
+              <a:t> is via HTTP protocol. Je </a:t>
+            </a:r>
+            <a:r>
+              <a:rPr lang="en-US" dirty="0" err="1">
+                <a:latin typeface="Calibri"/>
+                <a:ea typeface="Calibri"/>
+                <a:cs typeface="Calibri"/>
+              </a:rPr>
+              <a:t>moet</a:t>
+            </a:r>
+            <a:r>
+              <a:rPr lang="en-US" dirty="0">
+                <a:latin typeface="Calibri"/>
+                <a:ea typeface="Calibri"/>
+                <a:cs typeface="Calibri"/>
+              </a:rPr>
+              <a:t> het </a:t>
+            </a:r>
+            <a:r>
+              <a:rPr lang="en-US" dirty="0" err="1">
+                <a:latin typeface="Calibri"/>
+                <a:ea typeface="Calibri"/>
+                <a:cs typeface="Calibri"/>
+              </a:rPr>
+              <a:t>eindpunt</a:t>
+            </a:r>
+            <a:r>
+              <a:rPr lang="en-US" dirty="0">
+                <a:latin typeface="Calibri"/>
+                <a:ea typeface="Calibri"/>
+                <a:cs typeface="Calibri"/>
+              </a:rPr>
+              <a:t> </a:t>
+            </a:r>
+            <a:r>
+              <a:rPr lang="en-US" dirty="0" err="1">
+                <a:latin typeface="Calibri"/>
+                <a:ea typeface="Calibri"/>
+                <a:cs typeface="Calibri"/>
+              </a:rPr>
+              <a:t>ook</a:t>
+            </a:r>
+            <a:r>
+              <a:rPr lang="en-US" dirty="0">
+                <a:latin typeface="Calibri"/>
+                <a:ea typeface="Calibri"/>
+                <a:cs typeface="Calibri"/>
+              </a:rPr>
+              <a:t> </a:t>
+            </a:r>
+            <a:r>
+              <a:rPr lang="en-US" dirty="0" err="1">
+                <a:latin typeface="Calibri"/>
+                <a:ea typeface="Calibri"/>
+                <a:cs typeface="Calibri"/>
+              </a:rPr>
+              <a:t>kunnen</a:t>
+            </a:r>
+            <a:r>
+              <a:rPr lang="en-US" dirty="0">
+                <a:latin typeface="Calibri"/>
+                <a:ea typeface="Calibri"/>
+                <a:cs typeface="Calibri"/>
+              </a:rPr>
+              <a:t> </a:t>
+            </a:r>
+            <a:r>
+              <a:rPr lang="en-US" dirty="0" err="1">
+                <a:latin typeface="Calibri"/>
+                <a:ea typeface="Calibri"/>
+                <a:cs typeface="Calibri"/>
+              </a:rPr>
+              <a:t>bereiken</a:t>
+            </a:r>
+            <a:r>
+              <a:rPr lang="en-US" dirty="0">
+                <a:latin typeface="Calibri"/>
+                <a:ea typeface="Calibri"/>
+                <a:cs typeface="Calibri"/>
+              </a:rPr>
+              <a:t>: </a:t>
+            </a:r>
+            <a:r>
+              <a:rPr lang="en-US" dirty="0" err="1">
+                <a:latin typeface="Calibri"/>
+                <a:ea typeface="Calibri"/>
+                <a:cs typeface="Calibri"/>
+              </a:rPr>
+              <a:t>als</a:t>
+            </a:r>
+            <a:r>
+              <a:rPr lang="en-US" dirty="0">
+                <a:latin typeface="Calibri"/>
+                <a:ea typeface="Calibri"/>
+                <a:cs typeface="Calibri"/>
+              </a:rPr>
+              <a:t> de server plat </a:t>
+            </a:r>
+            <a:r>
+              <a:rPr lang="en-US" dirty="0" err="1">
+                <a:latin typeface="Calibri"/>
+                <a:ea typeface="Calibri"/>
+                <a:cs typeface="Calibri"/>
+              </a:rPr>
+              <a:t>ligt</a:t>
+            </a:r>
+            <a:r>
+              <a:rPr lang="en-US" dirty="0">
+                <a:latin typeface="Calibri"/>
+                <a:ea typeface="Calibri"/>
+                <a:cs typeface="Calibri"/>
+              </a:rPr>
+              <a:t>, of je </a:t>
+            </a:r>
+            <a:r>
+              <a:rPr lang="en-US" dirty="0" err="1">
+                <a:latin typeface="Calibri"/>
+                <a:ea typeface="Calibri"/>
+                <a:cs typeface="Calibri"/>
+              </a:rPr>
+              <a:t>hebt</a:t>
+            </a:r>
+            <a:r>
+              <a:rPr lang="en-US" dirty="0">
+                <a:latin typeface="Calibri"/>
+                <a:ea typeface="Calibri"/>
+                <a:cs typeface="Calibri"/>
+              </a:rPr>
+              <a:t> </a:t>
+            </a:r>
+            <a:r>
+              <a:rPr lang="en-US" dirty="0" err="1">
+                <a:latin typeface="Calibri"/>
+                <a:ea typeface="Calibri"/>
+                <a:cs typeface="Calibri"/>
+              </a:rPr>
+              <a:t>geen</a:t>
+            </a:r>
+            <a:r>
+              <a:rPr lang="en-US" dirty="0">
+                <a:latin typeface="Calibri"/>
+                <a:ea typeface="Calibri"/>
+                <a:cs typeface="Calibri"/>
+              </a:rPr>
+              <a:t> internet op het </a:t>
+            </a:r>
+            <a:r>
+              <a:rPr lang="en-US" dirty="0" err="1">
+                <a:latin typeface="Calibri"/>
+                <a:ea typeface="Calibri"/>
+                <a:cs typeface="Calibri"/>
+              </a:rPr>
+              <a:t>toestel</a:t>
+            </a:r>
+            <a:r>
+              <a:rPr lang="en-US" dirty="0">
+                <a:latin typeface="Calibri"/>
+                <a:ea typeface="Calibri"/>
+                <a:cs typeface="Calibri"/>
+              </a:rPr>
+              <a:t> </a:t>
+            </a:r>
+            <a:r>
+              <a:rPr lang="en-US" dirty="0" err="1">
+                <a:latin typeface="Calibri"/>
+                <a:ea typeface="Calibri"/>
+                <a:cs typeface="Calibri"/>
+              </a:rPr>
+              <a:t>waarop</a:t>
+            </a:r>
+            <a:r>
+              <a:rPr lang="en-US" dirty="0">
+                <a:latin typeface="Calibri"/>
+                <a:ea typeface="Calibri"/>
+                <a:cs typeface="Calibri"/>
+              </a:rPr>
+              <a:t> je </a:t>
+            </a:r>
+            <a:r>
+              <a:rPr lang="en-US" dirty="0" err="1">
+                <a:latin typeface="Calibri"/>
+                <a:ea typeface="Calibri"/>
+                <a:cs typeface="Calibri"/>
+              </a:rPr>
+              <a:t>een</a:t>
+            </a:r>
+            <a:r>
+              <a:rPr lang="en-US" dirty="0">
+                <a:latin typeface="Calibri"/>
+                <a:ea typeface="Calibri"/>
+                <a:cs typeface="Calibri"/>
+              </a:rPr>
+              <a:t> API request </a:t>
+            </a:r>
+            <a:r>
+              <a:rPr lang="en-US" dirty="0" err="1">
+                <a:latin typeface="Calibri"/>
+                <a:ea typeface="Calibri"/>
+                <a:cs typeface="Calibri"/>
+              </a:rPr>
+              <a:t>maakt</a:t>
+            </a:r>
+            <a:r>
+              <a:rPr lang="en-US" dirty="0">
+                <a:latin typeface="Calibri"/>
+                <a:ea typeface="Calibri"/>
+                <a:cs typeface="Calibri"/>
+              </a:rPr>
+              <a:t>: dan </a:t>
+            </a:r>
+            <a:r>
+              <a:rPr lang="en-US" dirty="0" err="1">
+                <a:latin typeface="Calibri"/>
+                <a:ea typeface="Calibri"/>
+                <a:cs typeface="Calibri"/>
+              </a:rPr>
+              <a:t>mislukt</a:t>
+            </a:r>
+            <a:r>
+              <a:rPr lang="en-US" dirty="0">
+                <a:latin typeface="Calibri"/>
+                <a:ea typeface="Calibri"/>
+                <a:cs typeface="Calibri"/>
+              </a:rPr>
+              <a:t> deze.</a:t>
+            </a:r>
+          </a:p>
+        </p:txBody>
+      </p:sp>
+      <p:sp>
+        <p:nvSpPr>
+          <p:cNvPr id="4" name="Tijdelijke aanduiding voor dianummer 3">
+            <a:extLst>
+              <a:ext uri="{FF2B5EF4-FFF2-40B4-BE49-F238E27FC236}">
+                <a16:creationId xmlns:a16="http://schemas.microsoft.com/office/drawing/2014/main" id="{5B0E9FE1-08F0-62CB-FA28-74A500BD6533}"/>
+              </a:ext>
+            </a:extLst>
+          </p:cNvPr>
+          <p:cNvSpPr>
+            <a:spLocks noGrp="1"/>
+          </p:cNvSpPr>
+          <p:nvPr>
+            <p:ph type="sldNum" sz="quarter" idx="5"/>
+          </p:nvPr>
+        </p:nvSpPr>
+        <p:spPr/>
+        <p:txBody>
+          <a:bodyPr/>
+          <a:lstStyle/>
+          <a:p>
+            <a:fld id="{39DBD449-D42A-4711-8837-53EC15580D9C}" type="slidenum">
+              <a:rPr lang="nl-BE" smtClean="0"/>
+              <a:t>5</a:t>
+            </a:fld>
+            <a:endParaRPr lang="nl-BE"/>
+          </a:p>
+        </p:txBody>
+      </p:sp>
+    </p:spTree>
+    <p:extLst>
+      <p:ext uri="{BB962C8B-B14F-4D97-AF65-F5344CB8AC3E}">
+        <p14:creationId xmlns:p14="http://schemas.microsoft.com/office/powerpoint/2010/main" val="4000523975"/>
+      </p:ext>
+    </p:extLst>
+  </p:cSld>
+  <p:clrMapOvr>
+    <a:masterClrMapping/>
+  </p:clrMapOvr>
+</p:notes>
+</file>
+
+<file path=ppt/notesSlides/notesSlide6.xml><?xml version="1.0" encoding="utf-8"?>
 <p:notes xmlns:a="http://schemas.openxmlformats.org/drawingml/2006/main" xmlns:r="http://schemas.openxmlformats.org/officeDocument/2006/relationships" xmlns:p="http://schemas.openxmlformats.org/presentationml/2006/main">
   <p:cSld>
     <p:spTree>
@@ -4159,7 +5334,7 @@
           <a:p>
             <a:fld id="{39DBD449-D42A-4711-8837-53EC15580D9C}" type="slidenum">
               <a:rPr lang="nl-BE" smtClean="0"/>
-              <a:t>4</a:t>
+              <a:t>5</a:t>
             </a:fld>
             <a:endParaRPr lang="nl-BE"/>
           </a:p>
@@ -8310,13 +9485,13 @@
   <p:clrMapOvr>
     <a:masterClrMapping/>
   </p:clrMapOvr>
-  <mc:AlternateContent xmlns:mc="http://schemas.openxmlformats.org/markup-compatibility/2006">
-    <mc:Choice xmlns:p14="http://schemas.microsoft.com/office/powerpoint/2010/main" Requires="p14">
+  <mc:AlternateContent xmlns:mc="http://schemas.openxmlformats.org/markup-compatibility/2006" xmlns:p14="http://schemas.microsoft.com/office/powerpoint/2010/main">
+    <mc:Choice Requires="p14">
       <p:transition spd="slow" p14:dur="4000">
         <p14:vortex dir="u"/>
       </p:transition>
     </mc:Choice>
-    <mc:Fallback>
+    <mc:Fallback xmlns="">
       <p:transition spd="slow">
         <p:fade/>
       </p:transition>
@@ -8395,7 +9570,7 @@
         <p:spPr/>
         <p:txBody>
           <a:bodyPr vert="horz" lIns="91440" tIns="45720" rIns="91440" bIns="45720" rtlCol="0" anchor="t">
-            <a:normAutofit fontScale="92500"/>
+            <a:normAutofit fontScale="92500" lnSpcReduction="10000"/>
           </a:bodyPr>
           <a:lstStyle/>
           <a:p>
@@ -8462,7 +9637,14 @@
             <a:pPr marL="0" indent="0">
               <a:buNone/>
             </a:pPr>
-            <a:endParaRPr lang="nl-NL" dirty="0"/>
+            <a:r>
+              <a:rPr lang="nl-NL"/>
+              <a:t>💡Tip! Experimenteer met de data die je terugkrijgt: dankzij print_r($result_of_json_decode) toon je (net zoals echo) wat in de array zit.</a:t>
+            </a:r>
+            <a:r>
+              <a:rPr lang="nl-NL" dirty="0"/>
+              <a:t> </a:t>
+            </a:r>
           </a:p>
           <a:p>
             <a:pPr marL="0" indent="0">
@@ -8512,6 +9694,171 @@
 </file>
 
 <file path=ppt/slides/slide5.xml><?xml version="1.0" encoding="utf-8"?>
+<p:sld xmlns:a="http://schemas.openxmlformats.org/drawingml/2006/main" xmlns:r="http://schemas.openxmlformats.org/officeDocument/2006/relationships" xmlns:p="http://schemas.openxmlformats.org/presentationml/2006/main">
+  <p:cSld>
+    <p:spTree>
+      <p:nvGrpSpPr>
+        <p:cNvPr id="1" name="">
+          <a:extLst>
+            <a:ext uri="{FF2B5EF4-FFF2-40B4-BE49-F238E27FC236}">
+              <a16:creationId xmlns:a16="http://schemas.microsoft.com/office/drawing/2014/main" id="{760B3BFC-5C8F-EEEE-346B-32AE0EB28DB6}"/>
+            </a:ext>
+          </a:extLst>
+        </p:cNvPr>
+        <p:cNvGrpSpPr/>
+        <p:nvPr/>
+      </p:nvGrpSpPr>
+      <p:grpSpPr>
+        <a:xfrm>
+          <a:off x="0" y="0"/>
+          <a:ext cx="0" cy="0"/>
+          <a:chOff x="0" y="0"/>
+          <a:chExt cx="0" cy="0"/>
+        </a:xfrm>
+      </p:grpSpPr>
+      <p:sp>
+        <p:nvSpPr>
+          <p:cNvPr id="2" name="Titel 1">
+            <a:extLst>
+              <a:ext uri="{FF2B5EF4-FFF2-40B4-BE49-F238E27FC236}">
+                <a16:creationId xmlns:a16="http://schemas.microsoft.com/office/drawing/2014/main" id="{0D7D052B-08F8-E576-ADA8-0A35AFAAB5CE}"/>
+              </a:ext>
+            </a:extLst>
+          </p:cNvPr>
+          <p:cNvSpPr>
+            <a:spLocks noGrp="1"/>
+          </p:cNvSpPr>
+          <p:nvPr>
+            <p:ph type="title"/>
+          </p:nvPr>
+        </p:nvSpPr>
+        <p:spPr/>
+        <p:txBody>
+          <a:bodyPr/>
+          <a:lstStyle/>
+          <a:p>
+            <a:r>
+              <a:rPr lang="nl-NL"/>
+              <a:t>Opdracht: Maak zelf een eenvoudige API</a:t>
+            </a:r>
+          </a:p>
+        </p:txBody>
+      </p:sp>
+      <p:sp>
+        <p:nvSpPr>
+          <p:cNvPr id="3" name="Tijdelijke aanduiding voor inhoud 2">
+            <a:extLst>
+              <a:ext uri="{FF2B5EF4-FFF2-40B4-BE49-F238E27FC236}">
+                <a16:creationId xmlns:a16="http://schemas.microsoft.com/office/drawing/2014/main" id="{58982348-23F4-38E3-F446-E9192CA847C5}"/>
+              </a:ext>
+            </a:extLst>
+          </p:cNvPr>
+          <p:cNvSpPr>
+            <a:spLocks noGrp="1"/>
+          </p:cNvSpPr>
+          <p:nvPr>
+            <p:ph idx="1"/>
+          </p:nvPr>
+        </p:nvSpPr>
+        <p:spPr/>
+        <p:txBody>
+          <a:bodyPr vert="horz" lIns="91440" tIns="45720" rIns="91440" bIns="45720" rtlCol="0" anchor="t">
+            <a:normAutofit/>
+          </a:bodyPr>
+          <a:lstStyle/>
+          <a:p>
+            <a:pPr>
+              <a:buNone/>
+            </a:pPr>
+            <a:r>
+              <a:rPr lang="nl-NL"/>
+              <a:t>Uit eerdere oefeningen (zoals de garage) hebben we al bestaande databases. =&gt; Ideale basis</a:t>
+            </a:r>
+          </a:p>
+          <a:p>
+            <a:pPr>
+              <a:buNone/>
+            </a:pPr>
+            <a:endParaRPr lang="nl-NL" dirty="0"/>
+          </a:p>
+          <a:p>
+            <a:pPr>
+              <a:buNone/>
+            </a:pPr>
+            <a:r>
+              <a:rPr lang="nl-NL"/>
+              <a:t>Maak enkele pagina's in een nieuwe workspace: get_all_users.php, get_all_vehicles.php</a:t>
+            </a:r>
+            <a:endParaRPr lang="nl-NL" dirty="0"/>
+          </a:p>
+          <a:p>
+            <a:pPr>
+              <a:buNone/>
+            </a:pPr>
+            <a:endParaRPr lang="nl-NL" dirty="0"/>
+          </a:p>
+          <a:p>
+            <a:pPr>
+              <a:buNone/>
+            </a:pPr>
+            <a:r>
+              <a:rPr lang="nl-NL" dirty="0"/>
+              <a:t>Deze pagina's moeten de data uit de DB halen, vervolgens encoderen met JSON </a:t>
+            </a:r>
+            <a:r>
+              <a:rPr lang="nl-NL"/>
+              <a:t>(json_encode) en terugsturen via "echo".</a:t>
+            </a:r>
+            <a:endParaRPr lang="nl-NL" dirty="0"/>
+          </a:p>
+          <a:p>
+            <a:pPr>
+              <a:buNone/>
+            </a:pPr>
+            <a:endParaRPr lang="nl-NL" dirty="0"/>
+          </a:p>
+          <a:p>
+            <a:pPr>
+              <a:buNone/>
+            </a:pPr>
+            <a:r>
+              <a:rPr lang="nl-NL" dirty="0"/>
+              <a:t>Let erop om de gevoelige velden zoals password of password_hash niet mee te sturen </a:t>
+            </a:r>
+            <a:r>
+              <a:rPr lang="nl-NL"/>
+              <a:t>(dus: SELECT * niet gebruiken, maar SELECT name, email, ….)</a:t>
+            </a:r>
+            <a:endParaRPr lang="nl-NL" dirty="0"/>
+          </a:p>
+        </p:txBody>
+      </p:sp>
+    </p:spTree>
+    <p:extLst>
+      <p:ext uri="{BB962C8B-B14F-4D97-AF65-F5344CB8AC3E}">
+        <p14:creationId xmlns:p14="http://schemas.microsoft.com/office/powerpoint/2010/main" val="217685725"/>
+      </p:ext>
+    </p:extLst>
+  </p:cSld>
+  <p:clrMapOvr>
+    <a:masterClrMapping/>
+  </p:clrMapOvr>
+  <mc:AlternateContent xmlns:mc="http://schemas.openxmlformats.org/markup-compatibility/2006">
+    <mc:Choice xmlns:p14="http://schemas.microsoft.com/office/powerpoint/2010/main" Requires="p14">
+      <p:transition spd="slow" p14:dur="4000">
+        <p14:vortex dir="u"/>
+      </p:transition>
+    </mc:Choice>
+    <mc:Fallback>
+      <p:transition spd="slow">
+        <p:fade/>
+      </p:transition>
+    </mc:Fallback>
+  </mc:AlternateContent>
+</p:sld>
+</file>
+
+<file path=ppt/slides/slide6.xml><?xml version="1.0" encoding="utf-8"?>
 <p:sld xmlns:a="http://schemas.openxmlformats.org/drawingml/2006/main" xmlns:r="http://schemas.openxmlformats.org/officeDocument/2006/relationships" xmlns:p="http://schemas.openxmlformats.org/presentationml/2006/main">
   <p:cSld>
     <p:bg>

</xml_diff>